<commit_message>
Renewals.pptx: tighten text sizes so labels fit inside media placeholders
Adjusts body/caption sizes around the chart and image placeholders so
copy stops getting clipped or wrapping awkwardly at the slot edges.
Template-only change; the python-pptx generation code is unchanged.

Co-Authored-By: Claude Opus 4.7 (1M context) <noreply@anthropic.com>
</commit_message>
<xml_diff>
--- a/Renewals.pptx
+++ b/Renewals.pptx
@@ -2301,7 +2301,7 @@
           <a:p>
             <a:pPr algn="ctr"/>
             <a:r>
-              <a:rPr lang="en-GB" sz="4000" dirty="0">
+              <a:rPr lang="en-GB" sz="2800" dirty="0">
                 <a:solidFill>
                   <a:schemeClr val="bg1"/>
                 </a:solidFill>
@@ -2310,7 +2310,7 @@
               <a:t>{{</a:t>
             </a:r>
             <a:r>
-              <a:rPr lang="en-GB" sz="4000" dirty="0" err="1">
+              <a:rPr lang="en-GB" sz="2800" dirty="0" err="1">
                 <a:solidFill>
                   <a:schemeClr val="bg1"/>
                 </a:solidFill>
@@ -2319,7 +2319,7 @@
               <a:t>stat_top_category</a:t>
             </a:r>
             <a:r>
-              <a:rPr lang="en-GB" sz="4000" dirty="0">
+              <a:rPr lang="en-GB" sz="2800" dirty="0">
                 <a:solidFill>
                   <a:schemeClr val="bg1"/>
                 </a:solidFill>
@@ -2327,7 +2327,7 @@
               </a:rPr>
               <a:t>}}</a:t>
             </a:r>
-            <a:endParaRPr lang="en-US" sz="4000" kern="0" spc="-67" dirty="0">
+            <a:endParaRPr lang="en-US" sz="2800" kern="0" spc="-67" dirty="0">
               <a:solidFill>
                 <a:schemeClr val="bg1"/>
               </a:solidFill>
@@ -5283,7 +5283,7 @@
           <a:p>
             <a:pPr algn="ctr"/>
             <a:r>
-              <a:rPr lang="en-GB" sz="3600" dirty="0">
+              <a:rPr lang="en-GB" sz="3000" dirty="0">
                 <a:solidFill>
                   <a:schemeClr val="bg1"/>
                 </a:solidFill>
@@ -5292,7 +5292,7 @@
               <a:t>{{</a:t>
             </a:r>
             <a:r>
-              <a:rPr lang="en-GB" sz="3600" dirty="0" err="1">
+              <a:rPr lang="en-GB" sz="3000" dirty="0" err="1">
                 <a:solidFill>
                   <a:schemeClr val="bg1"/>
                 </a:solidFill>
@@ -5301,7 +5301,7 @@
               <a:t>stat_total_jobs</a:t>
             </a:r>
             <a:r>
-              <a:rPr lang="en-GB" sz="3600" dirty="0">
+              <a:rPr lang="en-GB" sz="3000" dirty="0">
                 <a:solidFill>
                   <a:schemeClr val="bg1"/>
                 </a:solidFill>
@@ -5309,7 +5309,7 @@
               </a:rPr>
               <a:t>}}</a:t>
             </a:r>
-            <a:endParaRPr lang="en-US" sz="3600" dirty="0">
+            <a:endParaRPr lang="en-US" sz="3000" dirty="0">
               <a:solidFill>
                 <a:schemeClr val="bg1"/>
               </a:solidFill>
@@ -5415,7 +5415,7 @@
               </a:lnSpc>
             </a:pPr>
             <a:r>
-              <a:rPr lang="en-GB" sz="3600" dirty="0">
+              <a:rPr lang="en-GB" sz="3000" dirty="0">
                 <a:solidFill>
                   <a:srgbClr val="757575"/>
                 </a:solidFill>
@@ -5424,7 +5424,7 @@
               <a:t>{{</a:t>
             </a:r>
             <a:r>
-              <a:rPr lang="en-GB" sz="3600" dirty="0" err="1">
+              <a:rPr lang="en-GB" sz="3000" dirty="0" err="1">
                 <a:solidFill>
                   <a:srgbClr val="757575"/>
                 </a:solidFill>
@@ -5433,7 +5433,7 @@
               <a:t>stat_cost_per_job</a:t>
             </a:r>
             <a:r>
-              <a:rPr lang="en-GB" sz="3600" dirty="0">
+              <a:rPr lang="en-GB" sz="3000" dirty="0">
                 <a:solidFill>
                   <a:srgbClr val="757575"/>
                 </a:solidFill>
@@ -5441,7 +5441,7 @@
               </a:rPr>
               <a:t>}}</a:t>
             </a:r>
-            <a:endParaRPr lang="en-US" sz="3600" dirty="0">
+            <a:endParaRPr lang="en-US" sz="3000" dirty="0">
               <a:solidFill>
                 <a:srgbClr val="757575"/>
               </a:solidFill>
@@ -5554,7 +5554,7 @@
           <a:p>
             <a:pPr algn="ctr"/>
             <a:r>
-              <a:rPr lang="en-GB" sz="3600" dirty="0">
+              <a:rPr lang="en-GB" sz="3000" dirty="0">
                 <a:solidFill>
                   <a:schemeClr val="bg1"/>
                 </a:solidFill>
@@ -5563,7 +5563,7 @@
               <a:t>{{</a:t>
             </a:r>
             <a:r>
-              <a:rPr lang="en-GB" sz="3600" dirty="0" err="1">
+              <a:rPr lang="en-GB" sz="3000" dirty="0" err="1">
                 <a:solidFill>
                   <a:schemeClr val="bg1"/>
                 </a:solidFill>
@@ -5572,7 +5572,7 @@
               <a:t>stat_cost_per_view</a:t>
             </a:r>
             <a:r>
-              <a:rPr lang="en-GB" sz="3600" dirty="0">
+              <a:rPr lang="en-GB" sz="3000" dirty="0">
                 <a:solidFill>
                   <a:schemeClr val="bg1"/>
                 </a:solidFill>
@@ -5580,7 +5580,7 @@
               </a:rPr>
               <a:t>}}</a:t>
             </a:r>
-            <a:endParaRPr lang="en-US" sz="3600" dirty="0">
+            <a:endParaRPr lang="en-US" sz="3000" dirty="0">
               <a:solidFill>
                 <a:schemeClr val="bg1"/>
               </a:solidFill>
@@ -5686,7 +5686,7 @@
               </a:lnSpc>
             </a:pPr>
             <a:r>
-              <a:rPr lang="en-GB" sz="3600" dirty="0">
+              <a:rPr lang="en-GB" sz="3000" dirty="0">
                 <a:solidFill>
                   <a:srgbClr val="757575"/>
                 </a:solidFill>
@@ -5695,7 +5695,7 @@
               <a:t>{{</a:t>
             </a:r>
             <a:r>
-              <a:rPr lang="en-GB" sz="3600" dirty="0" err="1">
+              <a:rPr lang="en-GB" sz="3000" dirty="0" err="1">
                 <a:solidFill>
                   <a:srgbClr val="757575"/>
                 </a:solidFill>
@@ -5704,7 +5704,7 @@
               <a:t>stat_cost_per_apply</a:t>
             </a:r>
             <a:r>
-              <a:rPr lang="en-GB" sz="3600" dirty="0">
+              <a:rPr lang="en-GB" sz="3000" dirty="0">
                 <a:solidFill>
                   <a:srgbClr val="757575"/>
                 </a:solidFill>
@@ -5712,7 +5712,7 @@
               </a:rPr>
               <a:t>}}</a:t>
             </a:r>
-            <a:endParaRPr lang="en-US" sz="3600" dirty="0">
+            <a:endParaRPr lang="en-US" sz="3000" dirty="0">
               <a:solidFill>
                 <a:srgbClr val="757575"/>
               </a:solidFill>

</xml_diff>